<commit_message>
feat: agriflow screenshots, plain + illustrated report and slides (warm cream/green theme)
</commit_message>
<xml_diff>
--- a/AgriFlow_AI_Defence_Slides.pptx
+++ b/AgriFlow_AI_Defence_Slides.pptx
@@ -3095,7 +3095,7 @@
     <p:bg>
       <p:bgPr>
         <a:solidFill>
-          <a:srgbClr val="FFFFFF"/>
+          <a:srgbClr val="F8F3EE"/>
         </a:solidFill>
         <a:effectLst/>
       </p:bgPr>
@@ -3122,7 +3122,7 @@
             <a:avLst/>
           </a:prstGeom>
           <a:solidFill>
-            <a:srgbClr val="000000"/>
+            <a:srgbClr val="059669"/>
           </a:solidFill>
           <a:ln>
             <a:noFill/>
@@ -3166,7 +3166,7 @@
             <a:avLst/>
           </a:prstGeom>
           <a:solidFill>
-            <a:srgbClr val="000000"/>
+            <a:srgbClr val="059669"/>
           </a:solidFill>
           <a:ln>
             <a:noFill/>
@@ -3225,7 +3225,7 @@
             <a:r>
               <a:rPr sz="1500" b="1">
                 <a:solidFill>
-                  <a:srgbClr val="444444"/>
+                  <a:srgbClr val="047A55"/>
                 </a:solidFill>
                 <a:latin typeface="Segoe UI"/>
               </a:rPr>
@@ -3375,7 +3375,7 @@
             <a:avLst/>
           </a:prstGeom>
           <a:solidFill>
-            <a:srgbClr val="444444"/>
+            <a:srgbClr val="047A55"/>
           </a:solidFill>
           <a:ln>
             <a:noFill/>
@@ -3418,7 +3418,7 @@
     <p:bg>
       <p:bgPr>
         <a:solidFill>
-          <a:srgbClr val="FFFFFF"/>
+          <a:srgbClr val="F8F3EE"/>
         </a:solidFill>
         <a:effectLst/>
       </p:bgPr>
@@ -3460,7 +3460,7 @@
             <a:r>
               <a:rPr sz="1400" b="1">
                 <a:solidFill>
-                  <a:srgbClr val="000000"/>
+                  <a:srgbClr val="059669"/>
                 </a:solidFill>
                 <a:latin typeface="Segoe UI"/>
               </a:rPr>
@@ -3523,7 +3523,7 @@
             <a:avLst/>
           </a:prstGeom>
           <a:solidFill>
-            <a:srgbClr val="000000"/>
+            <a:srgbClr val="059669"/>
           </a:solidFill>
           <a:ln>
             <a:noFill/>
@@ -3669,7 +3669,7 @@
     <p:bg>
       <p:bgPr>
         <a:solidFill>
-          <a:srgbClr val="FFFFFF"/>
+          <a:srgbClr val="F8F3EE"/>
         </a:solidFill>
         <a:effectLst/>
       </p:bgPr>
@@ -3711,7 +3711,7 @@
             <a:r>
               <a:rPr sz="1400" b="1">
                 <a:solidFill>
-                  <a:srgbClr val="000000"/>
+                  <a:srgbClr val="059669"/>
                 </a:solidFill>
                 <a:latin typeface="Segoe UI"/>
               </a:rPr>
@@ -3774,7 +3774,7 @@
             <a:avLst/>
           </a:prstGeom>
           <a:solidFill>
-            <a:srgbClr val="000000"/>
+            <a:srgbClr val="059669"/>
           </a:solidFill>
           <a:ln>
             <a:noFill/>
@@ -3818,11 +3818,11 @@
             <a:avLst/>
           </a:prstGeom>
           <a:solidFill>
-            <a:srgbClr val="F4F4F4"/>
+            <a:srgbClr val="F0EBE6"/>
           </a:solidFill>
           <a:ln w="12700">
             <a:solidFill>
-              <a:srgbClr val="000000"/>
+              <a:srgbClr val="059669"/>
             </a:solidFill>
           </a:ln>
           <a:effectLst/>
@@ -3864,11 +3864,11 @@
             <a:avLst/>
           </a:prstGeom>
           <a:solidFill>
-            <a:srgbClr val="F4F4F4"/>
+            <a:srgbClr val="F0EBE6"/>
           </a:solidFill>
           <a:ln w="12700">
             <a:solidFill>
-              <a:srgbClr val="000000"/>
+              <a:srgbClr val="059669"/>
             </a:solidFill>
           </a:ln>
           <a:effectLst/>
@@ -3925,7 +3925,7 @@
             <a:r>
               <a:rPr sz="1900" b="1">
                 <a:solidFill>
-                  <a:srgbClr val="000000"/>
+                  <a:srgbClr val="059669"/>
                 </a:solidFill>
                 <a:latin typeface="Segoe UI"/>
               </a:rPr>
@@ -4019,7 +4019,7 @@
             <a:r>
               <a:rPr sz="1900" b="1">
                 <a:solidFill>
-                  <a:srgbClr val="444444"/>
+                  <a:srgbClr val="047A55"/>
                 </a:solidFill>
                 <a:latin typeface="Segoe UI"/>
               </a:rPr>
@@ -4177,7 +4177,7 @@
     <p:bg>
       <p:bgPr>
         <a:solidFill>
-          <a:srgbClr val="FFFFFF"/>
+          <a:srgbClr val="F8F3EE"/>
         </a:solidFill>
         <a:effectLst/>
       </p:bgPr>
@@ -4204,7 +4204,7 @@
             <a:avLst/>
           </a:prstGeom>
           <a:solidFill>
-            <a:srgbClr val="000000"/>
+            <a:srgbClr val="059669"/>
           </a:solidFill>
           <a:ln>
             <a:noFill/>
@@ -4302,7 +4302,7 @@
             <a:r>
               <a:rPr sz="2200" b="1">
                 <a:solidFill>
-                  <a:srgbClr val="000000"/>
+                  <a:srgbClr val="059669"/>
                 </a:solidFill>
                 <a:latin typeface="Segoe UI"/>
               </a:rPr>
@@ -4326,7 +4326,7 @@
             <a:avLst/>
           </a:prstGeom>
           <a:solidFill>
-            <a:srgbClr val="444444"/>
+            <a:srgbClr val="047A55"/>
           </a:solidFill>
           <a:ln>
             <a:noFill/>
@@ -4369,7 +4369,7 @@
     <p:bg>
       <p:bgPr>
         <a:solidFill>
-          <a:srgbClr val="FFFFFF"/>
+          <a:srgbClr val="F8F3EE"/>
         </a:solidFill>
         <a:effectLst/>
       </p:bgPr>
@@ -4411,7 +4411,7 @@
             <a:r>
               <a:rPr sz="1400" b="1">
                 <a:solidFill>
-                  <a:srgbClr val="000000"/>
+                  <a:srgbClr val="059669"/>
                 </a:solidFill>
                 <a:latin typeface="Segoe UI"/>
               </a:rPr>
@@ -4474,7 +4474,7 @@
             <a:avLst/>
           </a:prstGeom>
           <a:solidFill>
-            <a:srgbClr val="000000"/>
+            <a:srgbClr val="059669"/>
           </a:solidFill>
           <a:ln>
             <a:noFill/>
@@ -4620,7 +4620,7 @@
     <p:bg>
       <p:bgPr>
         <a:solidFill>
-          <a:srgbClr val="FFFFFF"/>
+          <a:srgbClr val="F8F3EE"/>
         </a:solidFill>
         <a:effectLst/>
       </p:bgPr>
@@ -4662,7 +4662,7 @@
             <a:r>
               <a:rPr sz="1400" b="1">
                 <a:solidFill>
-                  <a:srgbClr val="000000"/>
+                  <a:srgbClr val="059669"/>
                 </a:solidFill>
                 <a:latin typeface="Segoe UI"/>
               </a:rPr>
@@ -4725,7 +4725,7 @@
             <a:avLst/>
           </a:prstGeom>
           <a:solidFill>
-            <a:srgbClr val="000000"/>
+            <a:srgbClr val="059669"/>
           </a:solidFill>
           <a:ln>
             <a:noFill/>
@@ -4871,7 +4871,7 @@
     <p:bg>
       <p:bgPr>
         <a:solidFill>
-          <a:srgbClr val="FFFFFF"/>
+          <a:srgbClr val="F8F3EE"/>
         </a:solidFill>
         <a:effectLst/>
       </p:bgPr>
@@ -4913,7 +4913,7 @@
             <a:r>
               <a:rPr sz="1400" b="1">
                 <a:solidFill>
-                  <a:srgbClr val="000000"/>
+                  <a:srgbClr val="059669"/>
                 </a:solidFill>
                 <a:latin typeface="Segoe UI"/>
               </a:rPr>
@@ -4976,7 +4976,7 @@
             <a:avLst/>
           </a:prstGeom>
           <a:solidFill>
-            <a:srgbClr val="000000"/>
+            <a:srgbClr val="059669"/>
           </a:solidFill>
           <a:ln>
             <a:noFill/>
@@ -5020,11 +5020,11 @@
             <a:avLst/>
           </a:prstGeom>
           <a:solidFill>
-            <a:srgbClr val="F4F4F4"/>
+            <a:srgbClr val="F0EBE6"/>
           </a:solidFill>
           <a:ln w="12700">
             <a:solidFill>
-              <a:srgbClr val="000000"/>
+              <a:srgbClr val="059669"/>
             </a:solidFill>
           </a:ln>
           <a:effectLst/>
@@ -5066,11 +5066,11 @@
             <a:avLst/>
           </a:prstGeom>
           <a:solidFill>
-            <a:srgbClr val="F4F4F4"/>
+            <a:srgbClr val="F0EBE6"/>
           </a:solidFill>
           <a:ln w="12700">
             <a:solidFill>
-              <a:srgbClr val="000000"/>
+              <a:srgbClr val="059669"/>
             </a:solidFill>
           </a:ln>
           <a:effectLst/>
@@ -5127,7 +5127,7 @@
             <a:r>
               <a:rPr sz="1900" b="1">
                 <a:solidFill>
-                  <a:srgbClr val="000000"/>
+                  <a:srgbClr val="059669"/>
                 </a:solidFill>
                 <a:latin typeface="Segoe UI"/>
               </a:rPr>
@@ -5205,7 +5205,7 @@
             <a:r>
               <a:rPr sz="1900" b="1">
                 <a:solidFill>
-                  <a:srgbClr val="444444"/>
+                  <a:srgbClr val="047A55"/>
                 </a:solidFill>
                 <a:latin typeface="Segoe UI"/>
               </a:rPr>
@@ -5347,7 +5347,7 @@
     <p:bg>
       <p:bgPr>
         <a:solidFill>
-          <a:srgbClr val="FFFFFF"/>
+          <a:srgbClr val="F8F3EE"/>
         </a:solidFill>
         <a:effectLst/>
       </p:bgPr>
@@ -5389,7 +5389,7 @@
             <a:r>
               <a:rPr sz="1400" b="1">
                 <a:solidFill>
-                  <a:srgbClr val="000000"/>
+                  <a:srgbClr val="059669"/>
                 </a:solidFill>
                 <a:latin typeface="Segoe UI"/>
               </a:rPr>
@@ -5452,7 +5452,7 @@
             <a:avLst/>
           </a:prstGeom>
           <a:solidFill>
-            <a:srgbClr val="000000"/>
+            <a:srgbClr val="059669"/>
           </a:solidFill>
           <a:ln>
             <a:noFill/>
@@ -5582,7 +5582,7 @@
     <p:bg>
       <p:bgPr>
         <a:solidFill>
-          <a:srgbClr val="FFFFFF"/>
+          <a:srgbClr val="F8F3EE"/>
         </a:solidFill>
         <a:effectLst/>
       </p:bgPr>
@@ -5624,7 +5624,7 @@
             <a:r>
               <a:rPr sz="1400" b="1">
                 <a:solidFill>
-                  <a:srgbClr val="000000"/>
+                  <a:srgbClr val="059669"/>
                 </a:solidFill>
                 <a:latin typeface="Segoe UI"/>
               </a:rPr>
@@ -5687,7 +5687,7 @@
             <a:avLst/>
           </a:prstGeom>
           <a:solidFill>
-            <a:srgbClr val="000000"/>
+            <a:srgbClr val="059669"/>
           </a:solidFill>
           <a:ln>
             <a:noFill/>
@@ -5833,7 +5833,7 @@
     <p:bg>
       <p:bgPr>
         <a:solidFill>
-          <a:srgbClr val="FFFFFF"/>
+          <a:srgbClr val="F8F3EE"/>
         </a:solidFill>
         <a:effectLst/>
       </p:bgPr>
@@ -5875,7 +5875,7 @@
             <a:r>
               <a:rPr sz="1400" b="1">
                 <a:solidFill>
-                  <a:srgbClr val="000000"/>
+                  <a:srgbClr val="059669"/>
                 </a:solidFill>
                 <a:latin typeface="Segoe UI"/>
               </a:rPr>
@@ -5938,7 +5938,7 @@
             <a:avLst/>
           </a:prstGeom>
           <a:solidFill>
-            <a:srgbClr val="000000"/>
+            <a:srgbClr val="059669"/>
           </a:solidFill>
           <a:ln>
             <a:noFill/>
@@ -5982,11 +5982,11 @@
             <a:avLst/>
           </a:prstGeom>
           <a:solidFill>
-            <a:srgbClr val="F4F4F4"/>
+            <a:srgbClr val="F0EBE6"/>
           </a:solidFill>
           <a:ln w="12700">
             <a:solidFill>
-              <a:srgbClr val="000000"/>
+              <a:srgbClr val="059669"/>
             </a:solidFill>
           </a:ln>
           <a:effectLst/>
@@ -6028,7 +6028,7 @@
             <a:avLst/>
           </a:prstGeom>
           <a:solidFill>
-            <a:srgbClr val="000000"/>
+            <a:srgbClr val="059669"/>
           </a:solidFill>
           <a:ln>
             <a:noFill/>
@@ -6150,11 +6150,11 @@
             <a:avLst/>
           </a:prstGeom>
           <a:solidFill>
-            <a:srgbClr val="F4F4F4"/>
+            <a:srgbClr val="F0EBE6"/>
           </a:solidFill>
           <a:ln w="12700">
             <a:solidFill>
-              <a:srgbClr val="000000"/>
+              <a:srgbClr val="059669"/>
             </a:solidFill>
           </a:ln>
           <a:effectLst/>
@@ -6196,7 +6196,7 @@
             <a:avLst/>
           </a:prstGeom>
           <a:solidFill>
-            <a:srgbClr val="444444"/>
+            <a:srgbClr val="047A55"/>
           </a:solidFill>
           <a:ln>
             <a:noFill/>
@@ -6318,11 +6318,11 @@
             <a:avLst/>
           </a:prstGeom>
           <a:solidFill>
-            <a:srgbClr val="F4F4F4"/>
+            <a:srgbClr val="F0EBE6"/>
           </a:solidFill>
           <a:ln w="12700">
             <a:solidFill>
-              <a:srgbClr val="000000"/>
+              <a:srgbClr val="059669"/>
             </a:solidFill>
           </a:ln>
           <a:effectLst/>
@@ -6364,7 +6364,7 @@
             <a:avLst/>
           </a:prstGeom>
           <a:solidFill>
-            <a:srgbClr val="000000"/>
+            <a:srgbClr val="059669"/>
           </a:solidFill>
           <a:ln>
             <a:noFill/>
@@ -6486,11 +6486,11 @@
             <a:avLst/>
           </a:prstGeom>
           <a:solidFill>
-            <a:srgbClr val="F4F4F4"/>
+            <a:srgbClr val="F0EBE6"/>
           </a:solidFill>
           <a:ln w="12700">
             <a:solidFill>
-              <a:srgbClr val="000000"/>
+              <a:srgbClr val="059669"/>
             </a:solidFill>
           </a:ln>
           <a:effectLst/>
@@ -6532,7 +6532,7 @@
             <a:avLst/>
           </a:prstGeom>
           <a:solidFill>
-            <a:srgbClr val="444444"/>
+            <a:srgbClr val="047A55"/>
           </a:solidFill>
           <a:ln>
             <a:noFill/>
@@ -6654,11 +6654,11 @@
             <a:avLst/>
           </a:prstGeom>
           <a:solidFill>
-            <a:srgbClr val="F4F4F4"/>
+            <a:srgbClr val="F0EBE6"/>
           </a:solidFill>
           <a:ln w="12700">
             <a:solidFill>
-              <a:srgbClr val="000000"/>
+              <a:srgbClr val="059669"/>
             </a:solidFill>
           </a:ln>
           <a:effectLst/>
@@ -6700,7 +6700,7 @@
             <a:avLst/>
           </a:prstGeom>
           <a:solidFill>
-            <a:srgbClr val="000000"/>
+            <a:srgbClr val="059669"/>
           </a:solidFill>
           <a:ln>
             <a:noFill/>
@@ -6822,11 +6822,11 @@
             <a:avLst/>
           </a:prstGeom>
           <a:solidFill>
-            <a:srgbClr val="F4F4F4"/>
+            <a:srgbClr val="F0EBE6"/>
           </a:solidFill>
           <a:ln w="12700">
             <a:solidFill>
-              <a:srgbClr val="000000"/>
+              <a:srgbClr val="059669"/>
             </a:solidFill>
           </a:ln>
           <a:effectLst/>
@@ -6868,7 +6868,7 @@
             <a:avLst/>
           </a:prstGeom>
           <a:solidFill>
-            <a:srgbClr val="444444"/>
+            <a:srgbClr val="047A55"/>
           </a:solidFill>
           <a:ln>
             <a:noFill/>
@@ -6989,7 +6989,7 @@
     <p:bg>
       <p:bgPr>
         <a:solidFill>
-          <a:srgbClr val="FFFFFF"/>
+          <a:srgbClr val="F8F3EE"/>
         </a:solidFill>
         <a:effectLst/>
       </p:bgPr>
@@ -7031,7 +7031,7 @@
             <a:r>
               <a:rPr sz="1400" b="1">
                 <a:solidFill>
-                  <a:srgbClr val="000000"/>
+                  <a:srgbClr val="059669"/>
                 </a:solidFill>
                 <a:latin typeface="Segoe UI"/>
               </a:rPr>
@@ -7094,7 +7094,7 @@
             <a:avLst/>
           </a:prstGeom>
           <a:solidFill>
-            <a:srgbClr val="000000"/>
+            <a:srgbClr val="059669"/>
           </a:solidFill>
           <a:ln>
             <a:noFill/>
@@ -7138,11 +7138,11 @@
             <a:avLst/>
           </a:prstGeom>
           <a:solidFill>
-            <a:srgbClr val="F4F4F4"/>
+            <a:srgbClr val="F0EBE6"/>
           </a:solidFill>
           <a:ln w="12700">
             <a:solidFill>
-              <a:srgbClr val="000000"/>
+              <a:srgbClr val="059669"/>
             </a:solidFill>
           </a:ln>
           <a:effectLst/>
@@ -7199,7 +7199,7 @@
             <a:r>
               <a:rPr sz="1500" b="1">
                 <a:solidFill>
-                  <a:srgbClr val="000000"/>
+                  <a:srgbClr val="059669"/>
                 </a:solidFill>
                 <a:latin typeface="Segoe UI"/>
               </a:rPr>
@@ -7225,7 +7225,7 @@
         <p:spPr>
           <a:xfrm>
             <a:off x="1005840" y="2441448"/>
-            <a:ext cx="4617720" cy="2886075"/>
+            <a:ext cx="4617720" cy="2597468"/>
           </a:xfrm>
           <a:prstGeom prst="rect">
             <a:avLst/>
@@ -7286,11 +7286,11 @@
             <a:avLst/>
           </a:prstGeom>
           <a:solidFill>
-            <a:srgbClr val="F4F4F4"/>
+            <a:srgbClr val="F0EBE6"/>
           </a:solidFill>
           <a:ln w="12700">
             <a:solidFill>
-              <a:srgbClr val="000000"/>
+              <a:srgbClr val="059669"/>
             </a:solidFill>
           </a:ln>
           <a:effectLst/>
@@ -7347,7 +7347,7 @@
             <a:r>
               <a:rPr sz="1500" b="1">
                 <a:solidFill>
-                  <a:srgbClr val="000000"/>
+                  <a:srgbClr val="059669"/>
                 </a:solidFill>
                 <a:latin typeface="Segoe UI"/>
               </a:rPr>
@@ -7358,14 +7358,14 @@
       </p:sp>
       <p:pic>
         <p:nvPicPr>
-          <p:cNvPr id="11" name="Picture 10" descr="dash-admin.png"/>
+          <p:cNvPr id="11" name="Picture 10" descr="dash-farmer.png"/>
           <p:cNvPicPr>
             <a:picLocks noChangeAspect="1"/>
           </p:cNvPicPr>
           <p:nvPr/>
         </p:nvPicPr>
         <p:blipFill>
-          <a:blip r:embed="rId3"/>
+          <a:blip r:embed="rId2"/>
           <a:stretch>
             <a:fillRect/>
           </a:stretch>
@@ -7373,7 +7373,7 @@
         <p:spPr>
           <a:xfrm>
             <a:off x="6537960" y="2441448"/>
-            <a:ext cx="4617720" cy="2886075"/>
+            <a:ext cx="4617720" cy="2597468"/>
           </a:xfrm>
           <a:prstGeom prst="rect">
             <a:avLst/>
@@ -7433,7 +7433,7 @@
     <p:bg>
       <p:bgPr>
         <a:solidFill>
-          <a:srgbClr val="FFFFFF"/>
+          <a:srgbClr val="F8F3EE"/>
         </a:solidFill>
         <a:effectLst/>
       </p:bgPr>
@@ -7475,7 +7475,7 @@
             <a:r>
               <a:rPr sz="1400" b="1">
                 <a:solidFill>
-                  <a:srgbClr val="000000"/>
+                  <a:srgbClr val="059669"/>
                 </a:solidFill>
                 <a:latin typeface="Segoe UI"/>
               </a:rPr>
@@ -7538,7 +7538,7 @@
             <a:avLst/>
           </a:prstGeom>
           <a:solidFill>
-            <a:srgbClr val="000000"/>
+            <a:srgbClr val="059669"/>
           </a:solidFill>
           <a:ln>
             <a:noFill/>
@@ -7582,11 +7582,11 @@
             <a:avLst/>
           </a:prstGeom>
           <a:solidFill>
-            <a:srgbClr val="F4F4F4"/>
+            <a:srgbClr val="F0EBE6"/>
           </a:solidFill>
           <a:ln w="12700">
             <a:solidFill>
-              <a:srgbClr val="000000"/>
+              <a:srgbClr val="059669"/>
             </a:solidFill>
           </a:ln>
           <a:effectLst/>
@@ -7643,7 +7643,7 @@
             <a:r>
               <a:rPr sz="1500" b="1">
                 <a:solidFill>
-                  <a:srgbClr val="000000"/>
+                  <a:srgbClr val="059669"/>
                 </a:solidFill>
                 <a:latin typeface="Segoe UI"/>
               </a:rPr>
@@ -7669,7 +7669,7 @@
         <p:spPr>
           <a:xfrm>
             <a:off x="1005840" y="2441448"/>
-            <a:ext cx="4617720" cy="2886075"/>
+            <a:ext cx="4617720" cy="2597468"/>
           </a:xfrm>
           <a:prstGeom prst="rect">
             <a:avLst/>
@@ -7730,11 +7730,11 @@
             <a:avLst/>
           </a:prstGeom>
           <a:solidFill>
-            <a:srgbClr val="F4F4F4"/>
+            <a:srgbClr val="F0EBE6"/>
           </a:solidFill>
           <a:ln w="12700">
             <a:solidFill>
-              <a:srgbClr val="000000"/>
+              <a:srgbClr val="059669"/>
             </a:solidFill>
           </a:ln>
           <a:effectLst/>
@@ -7791,7 +7791,7 @@
             <a:r>
               <a:rPr sz="1500" b="1">
                 <a:solidFill>
-                  <a:srgbClr val="000000"/>
+                  <a:srgbClr val="059669"/>
                 </a:solidFill>
                 <a:latin typeface="Segoe UI"/>
               </a:rPr>
@@ -7802,7 +7802,7 @@
       </p:sp>
       <p:pic>
         <p:nvPicPr>
-          <p:cNvPr id="11" name="Picture 10" descr="dash-transporter.png"/>
+          <p:cNvPr id="11" name="Picture 10" descr="dash-farmer.png"/>
           <p:cNvPicPr>
             <a:picLocks noChangeAspect="1"/>
           </p:cNvPicPr>
@@ -7817,7 +7817,7 @@
         <p:spPr>
           <a:xfrm>
             <a:off x="6537960" y="2441448"/>
-            <a:ext cx="4617720" cy="2886075"/>
+            <a:ext cx="4617720" cy="2597468"/>
           </a:xfrm>
           <a:prstGeom prst="rect">
             <a:avLst/>

</xml_diff>

<commit_message>
Revert "feat: agriflow screenshots, plain + illustrated report and slides (warm cream/green theme)"
This reverts commit b0fa636db4dd0aa6fc2c715cab9d3381859b68fb.
</commit_message>
<xml_diff>
--- a/AgriFlow_AI_Defence_Slides.pptx
+++ b/AgriFlow_AI_Defence_Slides.pptx
@@ -3095,7 +3095,7 @@
     <p:bg>
       <p:bgPr>
         <a:solidFill>
-          <a:srgbClr val="F8F3EE"/>
+          <a:srgbClr val="FFFFFF"/>
         </a:solidFill>
         <a:effectLst/>
       </p:bgPr>
@@ -3122,7 +3122,7 @@
             <a:avLst/>
           </a:prstGeom>
           <a:solidFill>
-            <a:srgbClr val="059669"/>
+            <a:srgbClr val="000000"/>
           </a:solidFill>
           <a:ln>
             <a:noFill/>
@@ -3166,7 +3166,7 @@
             <a:avLst/>
           </a:prstGeom>
           <a:solidFill>
-            <a:srgbClr val="059669"/>
+            <a:srgbClr val="000000"/>
           </a:solidFill>
           <a:ln>
             <a:noFill/>
@@ -3225,7 +3225,7 @@
             <a:r>
               <a:rPr sz="1500" b="1">
                 <a:solidFill>
-                  <a:srgbClr val="047A55"/>
+                  <a:srgbClr val="444444"/>
                 </a:solidFill>
                 <a:latin typeface="Segoe UI"/>
               </a:rPr>
@@ -3375,7 +3375,7 @@
             <a:avLst/>
           </a:prstGeom>
           <a:solidFill>
-            <a:srgbClr val="047A55"/>
+            <a:srgbClr val="444444"/>
           </a:solidFill>
           <a:ln>
             <a:noFill/>
@@ -3418,7 +3418,7 @@
     <p:bg>
       <p:bgPr>
         <a:solidFill>
-          <a:srgbClr val="F8F3EE"/>
+          <a:srgbClr val="FFFFFF"/>
         </a:solidFill>
         <a:effectLst/>
       </p:bgPr>
@@ -3460,7 +3460,7 @@
             <a:r>
               <a:rPr sz="1400" b="1">
                 <a:solidFill>
-                  <a:srgbClr val="059669"/>
+                  <a:srgbClr val="000000"/>
                 </a:solidFill>
                 <a:latin typeface="Segoe UI"/>
               </a:rPr>
@@ -3523,7 +3523,7 @@
             <a:avLst/>
           </a:prstGeom>
           <a:solidFill>
-            <a:srgbClr val="059669"/>
+            <a:srgbClr val="000000"/>
           </a:solidFill>
           <a:ln>
             <a:noFill/>
@@ -3669,7 +3669,7 @@
     <p:bg>
       <p:bgPr>
         <a:solidFill>
-          <a:srgbClr val="F8F3EE"/>
+          <a:srgbClr val="FFFFFF"/>
         </a:solidFill>
         <a:effectLst/>
       </p:bgPr>
@@ -3711,7 +3711,7 @@
             <a:r>
               <a:rPr sz="1400" b="1">
                 <a:solidFill>
-                  <a:srgbClr val="059669"/>
+                  <a:srgbClr val="000000"/>
                 </a:solidFill>
                 <a:latin typeface="Segoe UI"/>
               </a:rPr>
@@ -3774,7 +3774,7 @@
             <a:avLst/>
           </a:prstGeom>
           <a:solidFill>
-            <a:srgbClr val="059669"/>
+            <a:srgbClr val="000000"/>
           </a:solidFill>
           <a:ln>
             <a:noFill/>
@@ -3818,11 +3818,11 @@
             <a:avLst/>
           </a:prstGeom>
           <a:solidFill>
-            <a:srgbClr val="F0EBE6"/>
+            <a:srgbClr val="F4F4F4"/>
           </a:solidFill>
           <a:ln w="12700">
             <a:solidFill>
-              <a:srgbClr val="059669"/>
+              <a:srgbClr val="000000"/>
             </a:solidFill>
           </a:ln>
           <a:effectLst/>
@@ -3864,11 +3864,11 @@
             <a:avLst/>
           </a:prstGeom>
           <a:solidFill>
-            <a:srgbClr val="F0EBE6"/>
+            <a:srgbClr val="F4F4F4"/>
           </a:solidFill>
           <a:ln w="12700">
             <a:solidFill>
-              <a:srgbClr val="059669"/>
+              <a:srgbClr val="000000"/>
             </a:solidFill>
           </a:ln>
           <a:effectLst/>
@@ -3925,7 +3925,7 @@
             <a:r>
               <a:rPr sz="1900" b="1">
                 <a:solidFill>
-                  <a:srgbClr val="059669"/>
+                  <a:srgbClr val="000000"/>
                 </a:solidFill>
                 <a:latin typeface="Segoe UI"/>
               </a:rPr>
@@ -4019,7 +4019,7 @@
             <a:r>
               <a:rPr sz="1900" b="1">
                 <a:solidFill>
-                  <a:srgbClr val="047A55"/>
+                  <a:srgbClr val="444444"/>
                 </a:solidFill>
                 <a:latin typeface="Segoe UI"/>
               </a:rPr>
@@ -4177,7 +4177,7 @@
     <p:bg>
       <p:bgPr>
         <a:solidFill>
-          <a:srgbClr val="F8F3EE"/>
+          <a:srgbClr val="FFFFFF"/>
         </a:solidFill>
         <a:effectLst/>
       </p:bgPr>
@@ -4204,7 +4204,7 @@
             <a:avLst/>
           </a:prstGeom>
           <a:solidFill>
-            <a:srgbClr val="059669"/>
+            <a:srgbClr val="000000"/>
           </a:solidFill>
           <a:ln>
             <a:noFill/>
@@ -4302,7 +4302,7 @@
             <a:r>
               <a:rPr sz="2200" b="1">
                 <a:solidFill>
-                  <a:srgbClr val="059669"/>
+                  <a:srgbClr val="000000"/>
                 </a:solidFill>
                 <a:latin typeface="Segoe UI"/>
               </a:rPr>
@@ -4326,7 +4326,7 @@
             <a:avLst/>
           </a:prstGeom>
           <a:solidFill>
-            <a:srgbClr val="047A55"/>
+            <a:srgbClr val="444444"/>
           </a:solidFill>
           <a:ln>
             <a:noFill/>
@@ -4369,7 +4369,7 @@
     <p:bg>
       <p:bgPr>
         <a:solidFill>
-          <a:srgbClr val="F8F3EE"/>
+          <a:srgbClr val="FFFFFF"/>
         </a:solidFill>
         <a:effectLst/>
       </p:bgPr>
@@ -4411,7 +4411,7 @@
             <a:r>
               <a:rPr sz="1400" b="1">
                 <a:solidFill>
-                  <a:srgbClr val="059669"/>
+                  <a:srgbClr val="000000"/>
                 </a:solidFill>
                 <a:latin typeface="Segoe UI"/>
               </a:rPr>
@@ -4474,7 +4474,7 @@
             <a:avLst/>
           </a:prstGeom>
           <a:solidFill>
-            <a:srgbClr val="059669"/>
+            <a:srgbClr val="000000"/>
           </a:solidFill>
           <a:ln>
             <a:noFill/>
@@ -4620,7 +4620,7 @@
     <p:bg>
       <p:bgPr>
         <a:solidFill>
-          <a:srgbClr val="F8F3EE"/>
+          <a:srgbClr val="FFFFFF"/>
         </a:solidFill>
         <a:effectLst/>
       </p:bgPr>
@@ -4662,7 +4662,7 @@
             <a:r>
               <a:rPr sz="1400" b="1">
                 <a:solidFill>
-                  <a:srgbClr val="059669"/>
+                  <a:srgbClr val="000000"/>
                 </a:solidFill>
                 <a:latin typeface="Segoe UI"/>
               </a:rPr>
@@ -4725,7 +4725,7 @@
             <a:avLst/>
           </a:prstGeom>
           <a:solidFill>
-            <a:srgbClr val="059669"/>
+            <a:srgbClr val="000000"/>
           </a:solidFill>
           <a:ln>
             <a:noFill/>
@@ -4871,7 +4871,7 @@
     <p:bg>
       <p:bgPr>
         <a:solidFill>
-          <a:srgbClr val="F8F3EE"/>
+          <a:srgbClr val="FFFFFF"/>
         </a:solidFill>
         <a:effectLst/>
       </p:bgPr>
@@ -4913,7 +4913,7 @@
             <a:r>
               <a:rPr sz="1400" b="1">
                 <a:solidFill>
-                  <a:srgbClr val="059669"/>
+                  <a:srgbClr val="000000"/>
                 </a:solidFill>
                 <a:latin typeface="Segoe UI"/>
               </a:rPr>
@@ -4976,7 +4976,7 @@
             <a:avLst/>
           </a:prstGeom>
           <a:solidFill>
-            <a:srgbClr val="059669"/>
+            <a:srgbClr val="000000"/>
           </a:solidFill>
           <a:ln>
             <a:noFill/>
@@ -5020,11 +5020,11 @@
             <a:avLst/>
           </a:prstGeom>
           <a:solidFill>
-            <a:srgbClr val="F0EBE6"/>
+            <a:srgbClr val="F4F4F4"/>
           </a:solidFill>
           <a:ln w="12700">
             <a:solidFill>
-              <a:srgbClr val="059669"/>
+              <a:srgbClr val="000000"/>
             </a:solidFill>
           </a:ln>
           <a:effectLst/>
@@ -5066,11 +5066,11 @@
             <a:avLst/>
           </a:prstGeom>
           <a:solidFill>
-            <a:srgbClr val="F0EBE6"/>
+            <a:srgbClr val="F4F4F4"/>
           </a:solidFill>
           <a:ln w="12700">
             <a:solidFill>
-              <a:srgbClr val="059669"/>
+              <a:srgbClr val="000000"/>
             </a:solidFill>
           </a:ln>
           <a:effectLst/>
@@ -5127,7 +5127,7 @@
             <a:r>
               <a:rPr sz="1900" b="1">
                 <a:solidFill>
-                  <a:srgbClr val="059669"/>
+                  <a:srgbClr val="000000"/>
                 </a:solidFill>
                 <a:latin typeface="Segoe UI"/>
               </a:rPr>
@@ -5205,7 +5205,7 @@
             <a:r>
               <a:rPr sz="1900" b="1">
                 <a:solidFill>
-                  <a:srgbClr val="047A55"/>
+                  <a:srgbClr val="444444"/>
                 </a:solidFill>
                 <a:latin typeface="Segoe UI"/>
               </a:rPr>
@@ -5347,7 +5347,7 @@
     <p:bg>
       <p:bgPr>
         <a:solidFill>
-          <a:srgbClr val="F8F3EE"/>
+          <a:srgbClr val="FFFFFF"/>
         </a:solidFill>
         <a:effectLst/>
       </p:bgPr>
@@ -5389,7 +5389,7 @@
             <a:r>
               <a:rPr sz="1400" b="1">
                 <a:solidFill>
-                  <a:srgbClr val="059669"/>
+                  <a:srgbClr val="000000"/>
                 </a:solidFill>
                 <a:latin typeface="Segoe UI"/>
               </a:rPr>
@@ -5452,7 +5452,7 @@
             <a:avLst/>
           </a:prstGeom>
           <a:solidFill>
-            <a:srgbClr val="059669"/>
+            <a:srgbClr val="000000"/>
           </a:solidFill>
           <a:ln>
             <a:noFill/>
@@ -5582,7 +5582,7 @@
     <p:bg>
       <p:bgPr>
         <a:solidFill>
-          <a:srgbClr val="F8F3EE"/>
+          <a:srgbClr val="FFFFFF"/>
         </a:solidFill>
         <a:effectLst/>
       </p:bgPr>
@@ -5624,7 +5624,7 @@
             <a:r>
               <a:rPr sz="1400" b="1">
                 <a:solidFill>
-                  <a:srgbClr val="059669"/>
+                  <a:srgbClr val="000000"/>
                 </a:solidFill>
                 <a:latin typeface="Segoe UI"/>
               </a:rPr>
@@ -5687,7 +5687,7 @@
             <a:avLst/>
           </a:prstGeom>
           <a:solidFill>
-            <a:srgbClr val="059669"/>
+            <a:srgbClr val="000000"/>
           </a:solidFill>
           <a:ln>
             <a:noFill/>
@@ -5833,7 +5833,7 @@
     <p:bg>
       <p:bgPr>
         <a:solidFill>
-          <a:srgbClr val="F8F3EE"/>
+          <a:srgbClr val="FFFFFF"/>
         </a:solidFill>
         <a:effectLst/>
       </p:bgPr>
@@ -5875,7 +5875,7 @@
             <a:r>
               <a:rPr sz="1400" b="1">
                 <a:solidFill>
-                  <a:srgbClr val="059669"/>
+                  <a:srgbClr val="000000"/>
                 </a:solidFill>
                 <a:latin typeface="Segoe UI"/>
               </a:rPr>
@@ -5938,7 +5938,7 @@
             <a:avLst/>
           </a:prstGeom>
           <a:solidFill>
-            <a:srgbClr val="059669"/>
+            <a:srgbClr val="000000"/>
           </a:solidFill>
           <a:ln>
             <a:noFill/>
@@ -5982,11 +5982,11 @@
             <a:avLst/>
           </a:prstGeom>
           <a:solidFill>
-            <a:srgbClr val="F0EBE6"/>
+            <a:srgbClr val="F4F4F4"/>
           </a:solidFill>
           <a:ln w="12700">
             <a:solidFill>
-              <a:srgbClr val="059669"/>
+              <a:srgbClr val="000000"/>
             </a:solidFill>
           </a:ln>
           <a:effectLst/>
@@ -6028,7 +6028,7 @@
             <a:avLst/>
           </a:prstGeom>
           <a:solidFill>
-            <a:srgbClr val="059669"/>
+            <a:srgbClr val="000000"/>
           </a:solidFill>
           <a:ln>
             <a:noFill/>
@@ -6150,11 +6150,11 @@
             <a:avLst/>
           </a:prstGeom>
           <a:solidFill>
-            <a:srgbClr val="F0EBE6"/>
+            <a:srgbClr val="F4F4F4"/>
           </a:solidFill>
           <a:ln w="12700">
             <a:solidFill>
-              <a:srgbClr val="059669"/>
+              <a:srgbClr val="000000"/>
             </a:solidFill>
           </a:ln>
           <a:effectLst/>
@@ -6196,7 +6196,7 @@
             <a:avLst/>
           </a:prstGeom>
           <a:solidFill>
-            <a:srgbClr val="047A55"/>
+            <a:srgbClr val="444444"/>
           </a:solidFill>
           <a:ln>
             <a:noFill/>
@@ -6318,11 +6318,11 @@
             <a:avLst/>
           </a:prstGeom>
           <a:solidFill>
-            <a:srgbClr val="F0EBE6"/>
+            <a:srgbClr val="F4F4F4"/>
           </a:solidFill>
           <a:ln w="12700">
             <a:solidFill>
-              <a:srgbClr val="059669"/>
+              <a:srgbClr val="000000"/>
             </a:solidFill>
           </a:ln>
           <a:effectLst/>
@@ -6364,7 +6364,7 @@
             <a:avLst/>
           </a:prstGeom>
           <a:solidFill>
-            <a:srgbClr val="059669"/>
+            <a:srgbClr val="000000"/>
           </a:solidFill>
           <a:ln>
             <a:noFill/>
@@ -6486,11 +6486,11 @@
             <a:avLst/>
           </a:prstGeom>
           <a:solidFill>
-            <a:srgbClr val="F0EBE6"/>
+            <a:srgbClr val="F4F4F4"/>
           </a:solidFill>
           <a:ln w="12700">
             <a:solidFill>
-              <a:srgbClr val="059669"/>
+              <a:srgbClr val="000000"/>
             </a:solidFill>
           </a:ln>
           <a:effectLst/>
@@ -6532,7 +6532,7 @@
             <a:avLst/>
           </a:prstGeom>
           <a:solidFill>
-            <a:srgbClr val="047A55"/>
+            <a:srgbClr val="444444"/>
           </a:solidFill>
           <a:ln>
             <a:noFill/>
@@ -6654,11 +6654,11 @@
             <a:avLst/>
           </a:prstGeom>
           <a:solidFill>
-            <a:srgbClr val="F0EBE6"/>
+            <a:srgbClr val="F4F4F4"/>
           </a:solidFill>
           <a:ln w="12700">
             <a:solidFill>
-              <a:srgbClr val="059669"/>
+              <a:srgbClr val="000000"/>
             </a:solidFill>
           </a:ln>
           <a:effectLst/>
@@ -6700,7 +6700,7 @@
             <a:avLst/>
           </a:prstGeom>
           <a:solidFill>
-            <a:srgbClr val="059669"/>
+            <a:srgbClr val="000000"/>
           </a:solidFill>
           <a:ln>
             <a:noFill/>
@@ -6822,11 +6822,11 @@
             <a:avLst/>
           </a:prstGeom>
           <a:solidFill>
-            <a:srgbClr val="F0EBE6"/>
+            <a:srgbClr val="F4F4F4"/>
           </a:solidFill>
           <a:ln w="12700">
             <a:solidFill>
-              <a:srgbClr val="059669"/>
+              <a:srgbClr val="000000"/>
             </a:solidFill>
           </a:ln>
           <a:effectLst/>
@@ -6868,7 +6868,7 @@
             <a:avLst/>
           </a:prstGeom>
           <a:solidFill>
-            <a:srgbClr val="047A55"/>
+            <a:srgbClr val="444444"/>
           </a:solidFill>
           <a:ln>
             <a:noFill/>
@@ -6989,7 +6989,7 @@
     <p:bg>
       <p:bgPr>
         <a:solidFill>
-          <a:srgbClr val="F8F3EE"/>
+          <a:srgbClr val="FFFFFF"/>
         </a:solidFill>
         <a:effectLst/>
       </p:bgPr>
@@ -7031,7 +7031,7 @@
             <a:r>
               <a:rPr sz="1400" b="1">
                 <a:solidFill>
-                  <a:srgbClr val="059669"/>
+                  <a:srgbClr val="000000"/>
                 </a:solidFill>
                 <a:latin typeface="Segoe UI"/>
               </a:rPr>
@@ -7094,7 +7094,7 @@
             <a:avLst/>
           </a:prstGeom>
           <a:solidFill>
-            <a:srgbClr val="059669"/>
+            <a:srgbClr val="000000"/>
           </a:solidFill>
           <a:ln>
             <a:noFill/>
@@ -7138,11 +7138,11 @@
             <a:avLst/>
           </a:prstGeom>
           <a:solidFill>
-            <a:srgbClr val="F0EBE6"/>
+            <a:srgbClr val="F4F4F4"/>
           </a:solidFill>
           <a:ln w="12700">
             <a:solidFill>
-              <a:srgbClr val="059669"/>
+              <a:srgbClr val="000000"/>
             </a:solidFill>
           </a:ln>
           <a:effectLst/>
@@ -7199,7 +7199,7 @@
             <a:r>
               <a:rPr sz="1500" b="1">
                 <a:solidFill>
-                  <a:srgbClr val="059669"/>
+                  <a:srgbClr val="000000"/>
                 </a:solidFill>
                 <a:latin typeface="Segoe UI"/>
               </a:rPr>
@@ -7225,7 +7225,7 @@
         <p:spPr>
           <a:xfrm>
             <a:off x="1005840" y="2441448"/>
-            <a:ext cx="4617720" cy="2597468"/>
+            <a:ext cx="4617720" cy="2886075"/>
           </a:xfrm>
           <a:prstGeom prst="rect">
             <a:avLst/>
@@ -7286,11 +7286,11 @@
             <a:avLst/>
           </a:prstGeom>
           <a:solidFill>
-            <a:srgbClr val="F0EBE6"/>
+            <a:srgbClr val="F4F4F4"/>
           </a:solidFill>
           <a:ln w="12700">
             <a:solidFill>
-              <a:srgbClr val="059669"/>
+              <a:srgbClr val="000000"/>
             </a:solidFill>
           </a:ln>
           <a:effectLst/>
@@ -7347,7 +7347,7 @@
             <a:r>
               <a:rPr sz="1500" b="1">
                 <a:solidFill>
-                  <a:srgbClr val="059669"/>
+                  <a:srgbClr val="000000"/>
                 </a:solidFill>
                 <a:latin typeface="Segoe UI"/>
               </a:rPr>
@@ -7358,14 +7358,14 @@
       </p:sp>
       <p:pic>
         <p:nvPicPr>
-          <p:cNvPr id="11" name="Picture 10" descr="dash-farmer.png"/>
+          <p:cNvPr id="11" name="Picture 10" descr="dash-admin.png"/>
           <p:cNvPicPr>
             <a:picLocks noChangeAspect="1"/>
           </p:cNvPicPr>
           <p:nvPr/>
         </p:nvPicPr>
         <p:blipFill>
-          <a:blip r:embed="rId2"/>
+          <a:blip r:embed="rId3"/>
           <a:stretch>
             <a:fillRect/>
           </a:stretch>
@@ -7373,7 +7373,7 @@
         <p:spPr>
           <a:xfrm>
             <a:off x="6537960" y="2441448"/>
-            <a:ext cx="4617720" cy="2597468"/>
+            <a:ext cx="4617720" cy="2886075"/>
           </a:xfrm>
           <a:prstGeom prst="rect">
             <a:avLst/>
@@ -7433,7 +7433,7 @@
     <p:bg>
       <p:bgPr>
         <a:solidFill>
-          <a:srgbClr val="F8F3EE"/>
+          <a:srgbClr val="FFFFFF"/>
         </a:solidFill>
         <a:effectLst/>
       </p:bgPr>
@@ -7475,7 +7475,7 @@
             <a:r>
               <a:rPr sz="1400" b="1">
                 <a:solidFill>
-                  <a:srgbClr val="059669"/>
+                  <a:srgbClr val="000000"/>
                 </a:solidFill>
                 <a:latin typeface="Segoe UI"/>
               </a:rPr>
@@ -7538,7 +7538,7 @@
             <a:avLst/>
           </a:prstGeom>
           <a:solidFill>
-            <a:srgbClr val="059669"/>
+            <a:srgbClr val="000000"/>
           </a:solidFill>
           <a:ln>
             <a:noFill/>
@@ -7582,11 +7582,11 @@
             <a:avLst/>
           </a:prstGeom>
           <a:solidFill>
-            <a:srgbClr val="F0EBE6"/>
+            <a:srgbClr val="F4F4F4"/>
           </a:solidFill>
           <a:ln w="12700">
             <a:solidFill>
-              <a:srgbClr val="059669"/>
+              <a:srgbClr val="000000"/>
             </a:solidFill>
           </a:ln>
           <a:effectLst/>
@@ -7643,7 +7643,7 @@
             <a:r>
               <a:rPr sz="1500" b="1">
                 <a:solidFill>
-                  <a:srgbClr val="059669"/>
+                  <a:srgbClr val="000000"/>
                 </a:solidFill>
                 <a:latin typeface="Segoe UI"/>
               </a:rPr>
@@ -7669,7 +7669,7 @@
         <p:spPr>
           <a:xfrm>
             <a:off x="1005840" y="2441448"/>
-            <a:ext cx="4617720" cy="2597468"/>
+            <a:ext cx="4617720" cy="2886075"/>
           </a:xfrm>
           <a:prstGeom prst="rect">
             <a:avLst/>
@@ -7730,11 +7730,11 @@
             <a:avLst/>
           </a:prstGeom>
           <a:solidFill>
-            <a:srgbClr val="F0EBE6"/>
+            <a:srgbClr val="F4F4F4"/>
           </a:solidFill>
           <a:ln w="12700">
             <a:solidFill>
-              <a:srgbClr val="059669"/>
+              <a:srgbClr val="000000"/>
             </a:solidFill>
           </a:ln>
           <a:effectLst/>
@@ -7791,7 +7791,7 @@
             <a:r>
               <a:rPr sz="1500" b="1">
                 <a:solidFill>
-                  <a:srgbClr val="059669"/>
+                  <a:srgbClr val="000000"/>
                 </a:solidFill>
                 <a:latin typeface="Segoe UI"/>
               </a:rPr>
@@ -7802,7 +7802,7 @@
       </p:sp>
       <p:pic>
         <p:nvPicPr>
-          <p:cNvPr id="11" name="Picture 10" descr="dash-farmer.png"/>
+          <p:cNvPr id="11" name="Picture 10" descr="dash-transporter.png"/>
           <p:cNvPicPr>
             <a:picLocks noChangeAspect="1"/>
           </p:cNvPicPr>
@@ -7817,7 +7817,7 @@
         <p:spPr>
           <a:xfrm>
             <a:off x="6537960" y="2441448"/>
-            <a:ext cx="4617720" cy="2597468"/>
+            <a:ext cx="4617720" cy="2886075"/>
           </a:xfrm>
           <a:prstGeom prst="rect">
             <a:avLst/>

</xml_diff>